<commit_message>
Restore cloud deployment and update demo URL
</commit_message>
<xml_diff>
--- a/submission/Caspian_Guardian_AI_Python_Team_10_Slides.pptx
+++ b/submission/Caspian_Guardian_AI_Python_Team_10_Slides.pptx
@@ -2,22 +2,22 @@
 <file path=ppt/presentation.xml><?xml version="1.0" encoding="utf-8"?>
 <p:presentation xmlns:p="http://schemas.openxmlformats.org/presentationml/2006/main">
   <p:sldMasterIdLst>
-    <p:sldMasterId xmlns:r="http://schemas.openxmlformats.org/officeDocument/2006/relationships" id="2147483648" r:id="Rda25b11557a74294"/>
+    <p:sldMasterId xmlns:r="http://schemas.openxmlformats.org/officeDocument/2006/relationships" id="2147483648" r:id="R472bfa0725c74ac9"/>
   </p:sldMasterIdLst>
   <p:notesMasterIdLst>
-    <p:notesMasterId xmlns:r="http://schemas.openxmlformats.org/officeDocument/2006/relationships" r:id="Re2e4c2c461944bf1"/>
+    <p:notesMasterId xmlns:r="http://schemas.openxmlformats.org/officeDocument/2006/relationships" r:id="R45686b719d4f4f33"/>
   </p:notesMasterIdLst>
   <p:sldIdLst>
-    <p:sldId xmlns:r="http://schemas.openxmlformats.org/officeDocument/2006/relationships" id="256" r:id="R6cbed4c1980440b2"/>
-    <p:sldId xmlns:r="http://schemas.openxmlformats.org/officeDocument/2006/relationships" id="257" r:id="R427fc8cffe204701"/>
-    <p:sldId xmlns:r="http://schemas.openxmlformats.org/officeDocument/2006/relationships" id="258" r:id="R64f9c7a8dc254185"/>
-    <p:sldId xmlns:r="http://schemas.openxmlformats.org/officeDocument/2006/relationships" id="259" r:id="Ra110d93bcb094979"/>
-    <p:sldId xmlns:r="http://schemas.openxmlformats.org/officeDocument/2006/relationships" id="260" r:id="R36d77badc30949d8"/>
-    <p:sldId xmlns:r="http://schemas.openxmlformats.org/officeDocument/2006/relationships" id="261" r:id="Rbdb60c763d104651"/>
-    <p:sldId xmlns:r="http://schemas.openxmlformats.org/officeDocument/2006/relationships" id="262" r:id="Ra3c1f1c993eb4b23"/>
-    <p:sldId xmlns:r="http://schemas.openxmlformats.org/officeDocument/2006/relationships" id="263" r:id="R6139b7032d0147c6"/>
-    <p:sldId xmlns:r="http://schemas.openxmlformats.org/officeDocument/2006/relationships" id="264" r:id="R69eb220b01f54536"/>
-    <p:sldId xmlns:r="http://schemas.openxmlformats.org/officeDocument/2006/relationships" id="265" r:id="R989550bd772d4cd1"/>
+    <p:sldId xmlns:r="http://schemas.openxmlformats.org/officeDocument/2006/relationships" id="256" r:id="Re4ad30fa079f46fc"/>
+    <p:sldId xmlns:r="http://schemas.openxmlformats.org/officeDocument/2006/relationships" id="257" r:id="R35b3d3a7e73b4616"/>
+    <p:sldId xmlns:r="http://schemas.openxmlformats.org/officeDocument/2006/relationships" id="258" r:id="R195a23d925474a05"/>
+    <p:sldId xmlns:r="http://schemas.openxmlformats.org/officeDocument/2006/relationships" id="259" r:id="R74bd126c62494bb1"/>
+    <p:sldId xmlns:r="http://schemas.openxmlformats.org/officeDocument/2006/relationships" id="260" r:id="Ra1116ba00a9843a9"/>
+    <p:sldId xmlns:r="http://schemas.openxmlformats.org/officeDocument/2006/relationships" id="261" r:id="Re7cad309d4494c80"/>
+    <p:sldId xmlns:r="http://schemas.openxmlformats.org/officeDocument/2006/relationships" id="262" r:id="Rf693059fc9794703"/>
+    <p:sldId xmlns:r="http://schemas.openxmlformats.org/officeDocument/2006/relationships" id="263" r:id="Re9b9e75305b84abf"/>
+    <p:sldId xmlns:r="http://schemas.openxmlformats.org/officeDocument/2006/relationships" id="264" r:id="Re9be4aa4c28a4a99"/>
+    <p:sldId xmlns:r="http://schemas.openxmlformats.org/officeDocument/2006/relationships" id="265" r:id="Ra60f073c03f04e50"/>
   </p:sldIdLst>
   <p:sldSz cx="12192000" cy="6858000"/>
   <p:notesSz cx="6858000" cy="9144000"/>
@@ -461,7 +461,7 @@
           </a:p>
           <a:p xmlns:a="http://schemas.openxmlformats.org/drawingml/2006/main">
             <a:r>
-              <a:t>- Verified cloud MVP: https://caspian-guardian-live-r4wxrq4vpwq7cxvvq-5173.app.github.dev</a:t>
+              <a:t>- Verified cloud MVP: https://caspian-guardian-live-fresh-97wxqr74j4q9fwqq-5173.app.github.dev</a:t>
             </a:r>
           </a:p>
         </p:txBody>
@@ -541,7 +541,7 @@
           </a:p>
           <a:p xmlns:a="http://schemas.openxmlformats.org/drawingml/2006/main">
             <a:r>
-              <a:t>- Verified cloud MVP: https://caspian-guardian-live-r4wxrq4vpwq7cxvvq-5173.app.github.dev</a:t>
+              <a:t>- Verified cloud MVP: https://caspian-guardian-live-fresh-97wxqr74j4q9fwqq-5173.app.github.dev</a:t>
             </a:r>
           </a:p>
         </p:txBody>
@@ -621,7 +621,7 @@
           </a:p>
           <a:p xmlns:a="http://schemas.openxmlformats.org/drawingml/2006/main">
             <a:r>
-              <a:t>- Verified cloud MVP: https://caspian-guardian-live-r4wxrq4vpwq7cxvvq-5173.app.github.dev</a:t>
+              <a:t>- Verified cloud MVP: https://caspian-guardian-live-fresh-97wxqr74j4q9fwqq-5173.app.github.dev</a:t>
             </a:r>
           </a:p>
         </p:txBody>
@@ -701,7 +701,7 @@
           </a:p>
           <a:p xmlns:a="http://schemas.openxmlformats.org/drawingml/2006/main">
             <a:r>
-              <a:t>- Verified cloud MVP: https://caspian-guardian-live-r4wxrq4vpwq7cxvvq-5173.app.github.dev</a:t>
+              <a:t>- Verified cloud MVP: https://caspian-guardian-live-fresh-97wxqr74j4q9fwqq-5173.app.github.dev</a:t>
             </a:r>
           </a:p>
         </p:txBody>
@@ -781,7 +781,7 @@
           </a:p>
           <a:p xmlns:a="http://schemas.openxmlformats.org/drawingml/2006/main">
             <a:r>
-              <a:t>- Verified cloud MVP: https://caspian-guardian-live-r4wxrq4vpwq7cxvvq-5173.app.github.dev</a:t>
+              <a:t>- Verified cloud MVP: https://caspian-guardian-live-fresh-97wxqr74j4q9fwqq-5173.app.github.dev</a:t>
             </a:r>
           </a:p>
         </p:txBody>
@@ -861,7 +861,7 @@
           </a:p>
           <a:p xmlns:a="http://schemas.openxmlformats.org/drawingml/2006/main">
             <a:r>
-              <a:t>- Verified cloud MVP: https://caspian-guardian-live-r4wxrq4vpwq7cxvvq-5173.app.github.dev</a:t>
+              <a:t>- Verified cloud MVP: https://caspian-guardian-live-fresh-97wxqr74j4q9fwqq-5173.app.github.dev</a:t>
             </a:r>
           </a:p>
         </p:txBody>
@@ -941,7 +941,7 @@
           </a:p>
           <a:p xmlns:a="http://schemas.openxmlformats.org/drawingml/2006/main">
             <a:r>
-              <a:t>- Verified cloud MVP: https://caspian-guardian-live-r4wxrq4vpwq7cxvvq-5173.app.github.dev</a:t>
+              <a:t>- Verified cloud MVP: https://caspian-guardian-live-fresh-97wxqr74j4q9fwqq-5173.app.github.dev</a:t>
             </a:r>
           </a:p>
         </p:txBody>
@@ -1021,7 +1021,7 @@
           </a:p>
           <a:p xmlns:a="http://schemas.openxmlformats.org/drawingml/2006/main">
             <a:r>
-              <a:t>- Verified cloud MVP: https://caspian-guardian-live-r4wxrq4vpwq7cxvvq-5173.app.github.dev</a:t>
+              <a:t>- Verified cloud MVP: https://caspian-guardian-live-fresh-97wxqr74j4q9fwqq-5173.app.github.dev</a:t>
             </a:r>
           </a:p>
         </p:txBody>
@@ -1101,7 +1101,7 @@
           </a:p>
           <a:p xmlns:a="http://schemas.openxmlformats.org/drawingml/2006/main">
             <a:r>
-              <a:t>- Verified cloud MVP: https://caspian-guardian-live-r4wxrq4vpwq7cxvvq-5173.app.github.dev</a:t>
+              <a:t>- Verified cloud MVP: https://caspian-guardian-live-fresh-97wxqr74j4q9fwqq-5173.app.github.dev</a:t>
             </a:r>
           </a:p>
         </p:txBody>
@@ -1181,7 +1181,7 @@
           </a:p>
           <a:p xmlns:a="http://schemas.openxmlformats.org/drawingml/2006/main">
             <a:r>
-              <a:t>- Verified cloud MVP: https://caspian-guardian-live-r4wxrq4vpwq7cxvvq-5173.app.github.dev</a:t>
+              <a:t>- Verified cloud MVP: https://caspian-guardian-live-fresh-97wxqr74j4q9fwqq-5173.app.github.dev</a:t>
             </a:r>
           </a:p>
         </p:txBody>
@@ -1249,7 +1249,7 @@
   </p:cSld>
   <p:clrMap bg1="lt1" tx1="dk1" bg2="lt2" tx2="dk2" accent1="accent1" accent2="accent2" accent3="accent3" accent4="accent4" accent5="accent5" accent6="accent6" hlink="hlink" folHlink="folHlink"/>
   <p:sldLayoutIdLst>
-    <p:sldLayoutId xmlns:r="http://schemas.openxmlformats.org/officeDocument/2006/relationships" id="2147483649" r:id="R3e38c274790d46ef"/>
+    <p:sldLayoutId xmlns:r="http://schemas.openxmlformats.org/officeDocument/2006/relationships" id="2147483649" r:id="R579cd4626d89436e"/>
   </p:sldLayoutIdLst>
   <p:txStyles>
     <p:titleStyle>
@@ -8752,7 +8752,7 @@
           <p:nvPr/>
         </p:nvPicPr>
         <p:blipFill>
-          <a:blip xmlns:r="http://schemas.openxmlformats.org/officeDocument/2006/relationships" xmlns:a="http://schemas.openxmlformats.org/drawingml/2006/main" r:embed="Re75905fac929462a"/>
+          <a:blip xmlns:r="http://schemas.openxmlformats.org/officeDocument/2006/relationships" xmlns:a="http://schemas.openxmlformats.org/drawingml/2006/main" r:embed="Ra947fa03f658449d"/>
           <a:srcRect xmlns:a="http://schemas.openxmlformats.org/drawingml/2006/main" l="0" t="29023" r="0" b="29023"/>
           <a:stretch xmlns:a="http://schemas.openxmlformats.org/drawingml/2006/main">
             <a:fillRect l="0" t="0" r="0" b="0"/>

</xml_diff>